<commit_message>
fix(decks): correct phoneme/syllable breakdowns in 44 teaching decks
audit-decks.js found 84 phoneme breakdowns + 3 syllable splits that didn't
rejoin to their word — the AI had written phonetic spellings (-ly→"ee",
-ed→"t", move→"m·oo·v", soft-g→"j", s→"z") instead of the actual letters.
Re-segmented every broken word with a greedy grapheme splitter (guarantees
rejoin), fixed dissection (dis/sec/tion) and self-learning's hyphen, and
lowercased "Overeating". Rebuilt all 44 PPTX via buildDeck. Re-audit: 0
phoneme/syllable rejoin failures across all 320 decks.

Co-Authored-By: Claude Opus 4.8 <noreply@anthropic.com>
</commit_message>
<xml_diff>
--- a/output/wordlabs-argue-3day.pptx
+++ b/output/wordlabs-argue-3day.pptx
@@ -22855,11 +22855,11 @@
         <p:spPr>
           <a:xfrm>
             <a:off x="1874520" y="4096512"/>
-            <a:ext cx="6903720" cy="804672"/>
+            <a:ext cx="6903720" cy="658368"/>
           </a:xfrm>
           <a:prstGeom prst="rect">
             <a:avLst>
-              <a:gd name="adj" fmla="val 6818"/>
+              <a:gd name="adj" fmla="val 8333"/>
             </a:avLst>
           </a:prstGeom>
           <a:solidFill>
@@ -22882,11 +22882,11 @@
         <p:spPr>
           <a:xfrm>
             <a:off x="2124837" y="4169664"/>
-            <a:ext cx="685800" cy="384048"/>
+            <a:ext cx="685800" cy="475488"/>
           </a:xfrm>
           <a:prstGeom prst="rect">
             <a:avLst>
-              <a:gd name="adj" fmla="val 9524"/>
+              <a:gd name="adj" fmla="val 7692"/>
             </a:avLst>
           </a:prstGeom>
           <a:solidFill>
@@ -22909,7 +22909,7 @@
         <p:spPr>
           <a:xfrm>
             <a:off x="2124837" y="4169664"/>
-            <a:ext cx="685800" cy="384048"/>
+            <a:ext cx="685800" cy="475488"/>
           </a:xfrm>
           <a:prstGeom prst="rect">
             <a:avLst/>
@@ -22948,11 +22948,11 @@
         <p:spPr>
           <a:xfrm>
             <a:off x="3033522" y="4169664"/>
-            <a:ext cx="685800" cy="384048"/>
+            <a:ext cx="685800" cy="475488"/>
           </a:xfrm>
           <a:prstGeom prst="rect">
             <a:avLst>
-              <a:gd name="adj" fmla="val 9524"/>
+              <a:gd name="adj" fmla="val 7692"/>
             </a:avLst>
           </a:prstGeom>
           <a:solidFill>
@@ -22975,7 +22975,7 @@
         <p:spPr>
           <a:xfrm>
             <a:off x="3033522" y="4169664"/>
-            <a:ext cx="685800" cy="384048"/>
+            <a:ext cx="685800" cy="475488"/>
           </a:xfrm>
           <a:prstGeom prst="rect">
             <a:avLst/>
@@ -23014,11 +23014,11 @@
         <p:spPr>
           <a:xfrm>
             <a:off x="3942207" y="4169664"/>
-            <a:ext cx="685800" cy="384048"/>
+            <a:ext cx="685800" cy="475488"/>
           </a:xfrm>
           <a:prstGeom prst="rect">
             <a:avLst>
-              <a:gd name="adj" fmla="val 9524"/>
+              <a:gd name="adj" fmla="val 7692"/>
             </a:avLst>
           </a:prstGeom>
           <a:solidFill>
@@ -23041,7 +23041,7 @@
         <p:spPr>
           <a:xfrm>
             <a:off x="3942207" y="4169664"/>
-            <a:ext cx="685800" cy="384048"/>
+            <a:ext cx="685800" cy="475488"/>
           </a:xfrm>
           <a:prstGeom prst="rect">
             <a:avLst/>
@@ -23080,11 +23080,11 @@
         <p:spPr>
           <a:xfrm>
             <a:off x="4850892" y="4169664"/>
-            <a:ext cx="685800" cy="384048"/>
+            <a:ext cx="685800" cy="475488"/>
           </a:xfrm>
           <a:prstGeom prst="rect">
             <a:avLst>
-              <a:gd name="adj" fmla="val 9524"/>
+              <a:gd name="adj" fmla="val 7692"/>
             </a:avLst>
           </a:prstGeom>
           <a:solidFill>
@@ -23107,7 +23107,7 @@
         <p:spPr>
           <a:xfrm>
             <a:off x="4850892" y="4169664"/>
-            <a:ext cx="685800" cy="384048"/>
+            <a:ext cx="685800" cy="475488"/>
           </a:xfrm>
           <a:prstGeom prst="rect">
             <a:avLst/>
@@ -23146,11 +23146,11 @@
         <p:spPr>
           <a:xfrm>
             <a:off x="5759577" y="4169664"/>
-            <a:ext cx="685800" cy="384048"/>
+            <a:ext cx="685800" cy="475488"/>
           </a:xfrm>
           <a:prstGeom prst="rect">
             <a:avLst>
-              <a:gd name="adj" fmla="val 9524"/>
+              <a:gd name="adj" fmla="val 7692"/>
             </a:avLst>
           </a:prstGeom>
           <a:solidFill>
@@ -23173,7 +23173,7 @@
         <p:spPr>
           <a:xfrm>
             <a:off x="5759577" y="4169664"/>
-            <a:ext cx="685800" cy="384048"/>
+            <a:ext cx="685800" cy="475488"/>
           </a:xfrm>
           <a:prstGeom prst="rect">
             <a:avLst/>
@@ -23212,11 +23212,11 @@
         <p:spPr>
           <a:xfrm>
             <a:off x="6668262" y="4169664"/>
-            <a:ext cx="685800" cy="384048"/>
+            <a:ext cx="685800" cy="475488"/>
           </a:xfrm>
           <a:prstGeom prst="rect">
             <a:avLst>
-              <a:gd name="adj" fmla="val 9524"/>
+              <a:gd name="adj" fmla="val 7692"/>
             </a:avLst>
           </a:prstGeom>
           <a:solidFill>
@@ -23239,7 +23239,7 @@
         <p:spPr>
           <a:xfrm>
             <a:off x="6668262" y="4169664"/>
-            <a:ext cx="685800" cy="384048"/>
+            <a:ext cx="685800" cy="475488"/>
           </a:xfrm>
           <a:prstGeom prst="rect">
             <a:avLst/>
@@ -23278,11 +23278,11 @@
         <p:spPr>
           <a:xfrm>
             <a:off x="7576947" y="4169664"/>
-            <a:ext cx="685800" cy="384048"/>
+            <a:ext cx="685800" cy="475488"/>
           </a:xfrm>
           <a:prstGeom prst="rect">
             <a:avLst>
-              <a:gd name="adj" fmla="val 9524"/>
+              <a:gd name="adj" fmla="val 7692"/>
             </a:avLst>
           </a:prstGeom>
           <a:solidFill>
@@ -23305,7 +23305,7 @@
         <p:spPr>
           <a:xfrm>
             <a:off x="7576947" y="4169664"/>
-            <a:ext cx="685800" cy="384048"/>
+            <a:ext cx="685800" cy="475488"/>
           </a:xfrm>
           <a:prstGeom prst="rect">
             <a:avLst/>
@@ -23329,48 +23329,9 @@
                 <a:ea typeface="Trebuchet MS" pitchFamily="34" charset="-122"/>
                 <a:cs typeface="Trebuchet MS" pitchFamily="34" charset="-120"/>
               </a:rPr>
-              <a:t>ee</a:t>
+              <a:t>y</a:t>
             </a:r>
             <a:endParaRPr lang="en-US" sz="900" dirty="0"/>
-          </a:p>
-        </p:txBody>
-      </p:sp>
-      <p:sp>
-        <p:nvSpPr>
-          <p:cNvPr id="57" name="Text 55"/>
-          <p:cNvSpPr/>
-          <p:nvPr/>
-        </p:nvSpPr>
-        <p:spPr>
-          <a:xfrm>
-            <a:off x="7576947" y="4572000"/>
-            <a:ext cx="685800" cy="219456"/>
-          </a:xfrm>
-          <a:prstGeom prst="rect">
-            <a:avLst/>
-          </a:prstGeom>
-          <a:noFill/>
-          <a:ln/>
-        </p:spPr>
-        <p:txBody>
-          <a:bodyPr wrap="square" lIns="0" tIns="0" rIns="0" bIns="0" rtlCol="0" anchor="t"/>
-          <a:lstStyle/>
-          <a:p>
-            <a:pPr algn="ctr" indent="0" marL="0">
-              <a:buNone/>
-            </a:pPr>
-            <a:r>
-              <a:rPr lang="en-US" sz="750" i="1" dirty="0">
-                <a:solidFill>
-                  <a:srgbClr val="94A3B8"/>
-                </a:solidFill>
-                <a:latin typeface="Calibri" pitchFamily="34" charset="0"/>
-                <a:ea typeface="Calibri" pitchFamily="34" charset="-122"/>
-                <a:cs typeface="Calibri" pitchFamily="34" charset="-120"/>
-              </a:rPr>
-              <a:t>/ee/</a:t>
-            </a:r>
-            <a:endParaRPr lang="en-US" sz="750" dirty="0"/>
           </a:p>
         </p:txBody>
       </p:sp>
@@ -38621,7 +38582,7 @@
                 <a:ea typeface="Calibri" pitchFamily="34" charset="-122"/>
                 <a:cs typeface="Calibri" pitchFamily="34" charset="-120"/>
               </a:rPr>
-              <a:t>2.  The suffix '-ment' can be added to 'argue' to make the noun 'argument'.</a:t>
+              <a:t>2.  The root 'argue' comes from a Latin word meaning to dispute or make clear.</a:t>
             </a:r>
             <a:endParaRPr lang="en-US" sz="1300" dirty="0"/>
           </a:p>
@@ -38760,7 +38721,7 @@
                 <a:ea typeface="Calibri" pitchFamily="34" charset="-122"/>
                 <a:cs typeface="Calibri" pitchFamily="34" charset="-120"/>
               </a:rPr>
-              <a:t>3.  An argument can mean a set of reasons given to support an idea, not just a fight.</a:t>
+              <a:t>3.  The word 'arguably' has no suffix added to the root 'argue'.</a:t>
             </a:r>
             <a:endParaRPr lang="en-US" sz="1300" dirty="0"/>
           </a:p>
@@ -38783,11 +38744,11 @@
             </a:avLst>
           </a:prstGeom>
           <a:solidFill>
-            <a:srgbClr val="DCFCE7"/>
-          </a:solidFill>
-          <a:ln w="12700">
-            <a:solidFill>
-              <a:srgbClr val="16A34A"/>
+            <a:srgbClr val="FEE2E2"/>
+          </a:solidFill>
+          <a:ln w="12700">
+            <a:solidFill>
+              <a:srgbClr val="DC2626"/>
             </a:solidFill>
             <a:prstDash val="solid"/>
           </a:ln>
@@ -38820,13 +38781,13 @@
             <a:r>
               <a:rPr lang="en-US" sz="1100" b="1" dirty="0">
                 <a:solidFill>
-                  <a:srgbClr val="16A34A"/>
+                  <a:srgbClr val="DC2626"/>
                 </a:solidFill>
                 <a:latin typeface="Trebuchet MS" pitchFamily="34" charset="0"/>
                 <a:ea typeface="Trebuchet MS" pitchFamily="34" charset="-122"/>
                 <a:cs typeface="Trebuchet MS" pitchFamily="34" charset="-120"/>
               </a:rPr>
-              <a:t>TRUE</a:t>
+              <a:t>FALSE</a:t>
             </a:r>
             <a:endParaRPr lang="en-US" sz="1100" dirty="0"/>
           </a:p>
@@ -38899,7 +38860,7 @@
                 <a:ea typeface="Calibri" pitchFamily="34" charset="-122"/>
                 <a:cs typeface="Calibri" pitchFamily="34" charset="-120"/>
               </a:rPr>
-              <a:t>4.  The word 'arguably' has no suffix added to the root 'argue'.</a:t>
+              <a:t>4.  The suffix '-ment' can be added to 'argue' to make the noun 'argument'.</a:t>
             </a:r>
             <a:endParaRPr lang="en-US" sz="1300" dirty="0"/>
           </a:p>
@@ -38922,11 +38883,11 @@
             </a:avLst>
           </a:prstGeom>
           <a:solidFill>
-            <a:srgbClr val="FEE2E2"/>
-          </a:solidFill>
-          <a:ln w="12700">
-            <a:solidFill>
-              <a:srgbClr val="DC2626"/>
+            <a:srgbClr val="DCFCE7"/>
+          </a:solidFill>
+          <a:ln w="12700">
+            <a:solidFill>
+              <a:srgbClr val="16A34A"/>
             </a:solidFill>
             <a:prstDash val="solid"/>
           </a:ln>
@@ -38959,13 +38920,13 @@
             <a:r>
               <a:rPr lang="en-US" sz="1100" b="1" dirty="0">
                 <a:solidFill>
-                  <a:srgbClr val="DC2626"/>
+                  <a:srgbClr val="16A34A"/>
                 </a:solidFill>
                 <a:latin typeface="Trebuchet MS" pitchFamily="34" charset="0"/>
                 <a:ea typeface="Trebuchet MS" pitchFamily="34" charset="-122"/>
                 <a:cs typeface="Trebuchet MS" pitchFamily="34" charset="-120"/>
               </a:rPr>
-              <a:t>FALSE</a:t>
+              <a:t>TRUE</a:t>
             </a:r>
             <a:endParaRPr lang="en-US" sz="1100" dirty="0"/>
           </a:p>
@@ -39038,7 +38999,7 @@
                 <a:ea typeface="Calibri" pitchFamily="34" charset="-122"/>
                 <a:cs typeface="Calibri" pitchFamily="34" charset="-120"/>
               </a:rPr>
-              <a:t>5.  The root 'argue' comes from a Latin word meaning to dispute or make clear.</a:t>
+              <a:t>5.  An argument can mean a set of reasons given to support an idea, not just a fight.</a:t>
             </a:r>
             <a:endParaRPr lang="en-US" sz="1300" dirty="0"/>
           </a:p>

</xml_diff>